<commit_message>
Add town names to both decks (campaign table + footprint)
Labels each ZIP with its north-central Indiana town across both the PPTX
and HTML decks:
- Campaign table: 'Neighborhood' column showing Town · ZIP (Peru 46970,
  Rochester 46975, Greentown 46936, Montpelier 47359, Kokomo 46901,
  Dunkirk 47336, Russiaville 46979, Fairmount 46928)
- Opportunity footprint band: town names instead of bare ZIPs
- Efficiency slide: town names in the cards and 'where to lean in' callout
- Town names verified against USPS/ZIP references

Co-Authored-By: Claude Opus 4.8 <noreply@anthropic.com>
Claude-Session: https://claude.ai/code/session_01Cyq3zkcaFRihnz3XVtX9JE
</commit_message>
<xml_diff>
--- a/presentations/Digital-Lead-Campaign.pptx
+++ b/presentations/Digital-Lead-Campaign.pptx
@@ -1744,6 +1744,45 @@
           </a:p>
         </p:txBody>
       </p:sp>
+      <p:sp>
+        <p:nvSpPr>
+          <p:cNvPr id="7" name="Text 5"/>
+          <p:cNvSpPr/>
+          <p:nvPr/>
+        </p:nvSpPr>
+        <p:spPr>
+          <a:xfrm>
+            <a:off x="6979615" y="6263640"/>
+            <a:ext cx="4572000" cy="365760"/>
+          </a:xfrm>
+          <a:prstGeom prst="rect">
+            <a:avLst/>
+          </a:prstGeom>
+          <a:noFill/>
+          <a:ln/>
+        </p:spPr>
+        <p:txBody>
+          <a:bodyPr wrap="square" rtlCol="0" anchor="ctr"/>
+          <a:lstStyle/>
+          <a:p>
+            <a:pPr algn="r" indent="0" marL="0">
+              <a:buNone/>
+            </a:pPr>
+            <a:r>
+              <a:rPr lang="en-US" sz="1100" b="1" dirty="0">
+                <a:solidFill>
+                  <a:srgbClr val="E7E0CE"/>
+                </a:solidFill>
+                <a:latin typeface="Calibri" pitchFamily="34" charset="0"/>
+                <a:ea typeface="Calibri" pitchFamily="34" charset="-122"/>
+                <a:cs typeface="Calibri" pitchFamily="34" charset="-120"/>
+              </a:rPr>
+              <a:t>8-ZIP digital lead program</a:t>
+            </a:r>
+            <a:endParaRPr lang="en-US" sz="1100" dirty="0"/>
+          </a:p>
+        </p:txBody>
+      </p:sp>
     </p:spTree>
   </p:cSld>
   <p:clrMapOvr>
@@ -2592,7 +2631,7 @@
         <p:spPr>
           <a:xfrm>
             <a:off x="960120" y="5230368"/>
-            <a:ext cx="10058400" cy="310896"/>
+            <a:ext cx="10424160" cy="310896"/>
           </a:xfrm>
           <a:prstGeom prst="rect">
             <a:avLst/>
@@ -2608,7 +2647,7 @@
               <a:buNone/>
             </a:pPr>
             <a:r>
-              <a:rPr lang="en-US" sz="1500" b="1" dirty="0">
+              <a:rPr lang="en-US" sz="1350" b="1" dirty="0">
                 <a:solidFill>
                   <a:srgbClr val="FBF8EF"/>
                 </a:solidFill>
@@ -2616,9 +2655,9 @@
                 <a:ea typeface="Calibri" pitchFamily="34" charset="-122"/>
                 <a:cs typeface="Calibri" pitchFamily="34" charset="-120"/>
               </a:rPr>
-              <a:t>46970 · 46975 · 46936 · 47359 · 46901 · 47336 · 46979 · 46928</a:t>
-            </a:r>
-            <a:endParaRPr lang="en-US" sz="1500" dirty="0"/>
+              <a:t>Peru · Rochester · Greentown · Montpelier · Kokomo · Dunkirk · Russiaville · Fairmount</a:t>
+            </a:r>
+            <a:endParaRPr lang="en-US" sz="1350" dirty="0"/>
           </a:p>
         </p:txBody>
       </p:sp>
@@ -2631,7 +2670,7 @@
         <p:spPr>
           <a:xfrm>
             <a:off x="960120" y="5522976"/>
-            <a:ext cx="10058400" cy="274320"/>
+            <a:ext cx="10424160" cy="274320"/>
           </a:xfrm>
           <a:prstGeom prst="rect">
             <a:avLst/>
@@ -2973,12 +3012,12 @@
             <a:tbl>
               <a:tblPr/>
               <a:tblGrid>
-                <a:gridCol w="1463040"/>
+                <a:gridCol w="2148840"/>
+                <a:gridCol w="1691640"/>
+                <a:gridCol w="1691640"/>
+                <a:gridCol w="1645920"/>
+                <a:gridCol w="1828800"/>
                 <a:gridCol w="1874520"/>
-                <a:gridCol w="1874520"/>
-                <a:gridCol w="1828800"/>
-                <a:gridCol w="1920240"/>
-                <a:gridCol w="1920240"/>
               </a:tblGrid>
               <a:tr h="310896">
                 <a:tc>
@@ -2998,7 +3037,7 @@
                           <a:ea typeface="Calibri" pitchFamily="34" charset="-122"/>
                           <a:cs typeface="Calibri" pitchFamily="34" charset="-120"/>
                         </a:rPr>
-                        <a:t>ZIP</a:t>
+                        <a:t>Neighborhood</a:t>
                       </a:r>
                       <a:endParaRPr lang="en-US" sz="1000" dirty="0">
                         <a:latin typeface="Calibri" charset="0"/>
@@ -3408,7 +3447,7 @@
                           <a:ea typeface="Calibri" pitchFamily="34" charset="-122"/>
                           <a:cs typeface="Calibri" pitchFamily="34" charset="-120"/>
                         </a:rPr>
-                        <a:t>46970</a:t>
+                        <a:t>Peru · 46970</a:t>
                       </a:r>
                       <a:endParaRPr lang="en-US" sz="1150" dirty="0">
                         <a:latin typeface="Calibri" charset="0"/>
@@ -3800,7 +3839,7 @@
                           <a:ea typeface="Calibri" pitchFamily="34" charset="-122"/>
                           <a:cs typeface="Calibri" pitchFamily="34" charset="-120"/>
                         </a:rPr>
-                        <a:t>46975</a:t>
+                        <a:t>Rochester · 46975</a:t>
                       </a:r>
                       <a:endParaRPr lang="en-US" sz="1150" dirty="0">
                         <a:latin typeface="Calibri" charset="0"/>
@@ -4192,7 +4231,7 @@
                           <a:ea typeface="Calibri" pitchFamily="34" charset="-122"/>
                           <a:cs typeface="Calibri" pitchFamily="34" charset="-120"/>
                         </a:rPr>
-                        <a:t>46936</a:t>
+                        <a:t>Greentown · 46936</a:t>
                       </a:r>
                       <a:endParaRPr lang="en-US" sz="1150" dirty="0">
                         <a:latin typeface="Calibri" charset="0"/>
@@ -4584,7 +4623,7 @@
                           <a:ea typeface="Calibri" pitchFamily="34" charset="-122"/>
                           <a:cs typeface="Calibri" pitchFamily="34" charset="-120"/>
                         </a:rPr>
-                        <a:t>47359</a:t>
+                        <a:t>Montpelier · 47359</a:t>
                       </a:r>
                       <a:endParaRPr lang="en-US" sz="1150" dirty="0">
                         <a:latin typeface="Calibri" charset="0"/>
@@ -4976,7 +5015,7 @@
                           <a:ea typeface="Calibri" pitchFamily="34" charset="-122"/>
                           <a:cs typeface="Calibri" pitchFamily="34" charset="-120"/>
                         </a:rPr>
-                        <a:t>46901</a:t>
+                        <a:t>Kokomo · 46901</a:t>
                       </a:r>
                       <a:endParaRPr lang="en-US" sz="1150" dirty="0">
                         <a:latin typeface="Calibri" charset="0"/>
@@ -5368,7 +5407,7 @@
                           <a:ea typeface="Calibri" pitchFamily="34" charset="-122"/>
                           <a:cs typeface="Calibri" pitchFamily="34" charset="-120"/>
                         </a:rPr>
-                        <a:t>47336</a:t>
+                        <a:t>Dunkirk · 47336</a:t>
                       </a:r>
                       <a:endParaRPr lang="en-US" sz="1150" dirty="0">
                         <a:latin typeface="Calibri" charset="0"/>
@@ -5760,7 +5799,7 @@
                           <a:ea typeface="Calibri" pitchFamily="34" charset="-122"/>
                           <a:cs typeface="Calibri" pitchFamily="34" charset="-120"/>
                         </a:rPr>
-                        <a:t>46979</a:t>
+                        <a:t>Russiaville · 46979</a:t>
                       </a:r>
                       <a:endParaRPr lang="en-US" sz="1150" dirty="0">
                         <a:latin typeface="Calibri" charset="0"/>
@@ -6152,7 +6191,7 @@
                           <a:ea typeface="Calibri" pitchFamily="34" charset="-122"/>
                           <a:cs typeface="Calibri" pitchFamily="34" charset="-120"/>
                         </a:rPr>
-                        <a:t>46928</a:t>
+                        <a:t>Fairmount · 46928</a:t>
                       </a:r>
                       <a:endParaRPr lang="en-US" sz="1150" dirty="0">
                         <a:latin typeface="Calibri" charset="0"/>
@@ -6544,7 +6583,7 @@
                           <a:ea typeface="Cambria" pitchFamily="34" charset="-122"/>
                           <a:cs typeface="Cambria" pitchFamily="34" charset="-120"/>
                         </a:rPr>
-                        <a:t>8 ZIP codes</a:t>
+                        <a:t>8 neighborhoods</a:t>
                       </a:r>
                       <a:endParaRPr lang="en-US" sz="1150" dirty="0">
                         <a:latin typeface="Cambria" charset="0"/>
@@ -9334,7 +9373,7 @@
                 <a:ea typeface="Calibri" pitchFamily="34" charset="-122"/>
                 <a:cs typeface="Calibri" pitchFamily="34" charset="-120"/>
               </a:rPr>
-              <a:t>as low as $24 in 47359</a:t>
+              <a:t>as low as $24 in Montpelier</a:t>
             </a:r>
             <a:endParaRPr lang="en-US" sz="1100" dirty="0"/>
           </a:p>
@@ -9488,7 +9527,7 @@
                 <a:ea typeface="Calibri" pitchFamily="34" charset="-122"/>
                 <a:cs typeface="Calibri" pitchFamily="34" charset="-120"/>
               </a:rPr>
-              <a:t>46901, 46928, 46979</a:t>
+              <a:t>Kokomo, Fairmount, Russiaville</a:t>
             </a:r>
             <a:endParaRPr lang="en-US" sz="1100" dirty="0"/>
           </a:p>
@@ -9796,7 +9835,7 @@
                 <a:ea typeface="Calibri" pitchFamily="34" charset="-122"/>
                 <a:cs typeface="Calibri" pitchFamily="34" charset="-120"/>
               </a:rPr>
-              <a:t>46901 — wide open</a:t>
+              <a:t>Kokomo — wide open</a:t>
             </a:r>
             <a:endParaRPr lang="en-US" sz="1100" dirty="0"/>
           </a:p>
@@ -9882,7 +9921,7 @@
                 <a:ea typeface="Calibri" pitchFamily="34" charset="-122"/>
                 <a:cs typeface="Calibri" pitchFamily="34" charset="-120"/>
               </a:rPr>
-              <a:t>46901 (Kokomo) holds just 7.7% share of voice in a $191K market, and 47359 already converts at $24 per connection. Budget added here compounds — more voice where the market is open, more leads where they're cheapest.</a:t>
+              <a:t>Kokomo (46901) holds just 7.7% share of voice in a $191K market, and Montpelier (47359) already converts at $24 per connection. Budget added here compounds — more voice where the market is open, more leads where they're cheapest.</a:t>
             </a:r>
             <a:endParaRPr lang="en-US" sz="1250" dirty="0"/>
           </a:p>

</xml_diff>